<commit_message>
Refine portfolio decks and add source-backed Flint comparison
</commit_message>
<xml_diff>
--- a/downloads/ai/kyle-hobson-ai-deck.pptx
+++ b/downloads/ai/kyle-hobson-ai-deck.pptx
@@ -2,23 +2,23 @@
 <file path=ppt/presentation.xml><?xml version="1.0" encoding="utf-8"?>
 <p:presentation xmlns:p="http://schemas.openxmlformats.org/presentationml/2006/main">
   <p:sldMasterIdLst>
-    <p:sldMasterId xmlns:r="http://schemas.openxmlformats.org/officeDocument/2006/relationships" id="2147483648" r:id="Rb0f0750a8aa44c66"/>
+    <p:sldMasterId xmlns:r="http://schemas.openxmlformats.org/officeDocument/2006/relationships" id="2147483648" r:id="Rda529569b9e34b12"/>
   </p:sldMasterIdLst>
   <p:notesMasterIdLst>
-    <p:notesMasterId xmlns:r="http://schemas.openxmlformats.org/officeDocument/2006/relationships" r:id="R9d1b012b3c2c4fc7"/>
+    <p:notesMasterId xmlns:r="http://schemas.openxmlformats.org/officeDocument/2006/relationships" r:id="R50fd29ee5ab84f10"/>
   </p:notesMasterIdLst>
   <p:sldIdLst>
-    <p:sldId xmlns:r="http://schemas.openxmlformats.org/officeDocument/2006/relationships" id="256" r:id="R73990004356f425b"/>
-    <p:sldId xmlns:r="http://schemas.openxmlformats.org/officeDocument/2006/relationships" id="257" r:id="R3d7e15198b85437c"/>
-    <p:sldId xmlns:r="http://schemas.openxmlformats.org/officeDocument/2006/relationships" id="258" r:id="Rb68305b4865d4059"/>
-    <p:sldId xmlns:r="http://schemas.openxmlformats.org/officeDocument/2006/relationships" id="259" r:id="Re619f529be1d4d32"/>
-    <p:sldId xmlns:r="http://schemas.openxmlformats.org/officeDocument/2006/relationships" id="260" r:id="Rf9ae53b7128947b8"/>
-    <p:sldId xmlns:r="http://schemas.openxmlformats.org/officeDocument/2006/relationships" id="261" r:id="R027e3b6c2527432f"/>
-    <p:sldId xmlns:r="http://schemas.openxmlformats.org/officeDocument/2006/relationships" id="262" r:id="R27722e4d0615413d"/>
-    <p:sldId xmlns:r="http://schemas.openxmlformats.org/officeDocument/2006/relationships" id="263" r:id="Ra2e242fb4ac64ace"/>
-    <p:sldId xmlns:r="http://schemas.openxmlformats.org/officeDocument/2006/relationships" id="264" r:id="Ra034ea321d9441fa"/>
-    <p:sldId xmlns:r="http://schemas.openxmlformats.org/officeDocument/2006/relationships" id="265" r:id="R03bf054710cd449b"/>
-    <p:sldId xmlns:r="http://schemas.openxmlformats.org/officeDocument/2006/relationships" id="266" r:id="R21fae658692a4b65"/>
+    <p:sldId xmlns:r="http://schemas.openxmlformats.org/officeDocument/2006/relationships" id="256" r:id="Reaa0ba7922bf4e27"/>
+    <p:sldId xmlns:r="http://schemas.openxmlformats.org/officeDocument/2006/relationships" id="257" r:id="R6e2fe5131c8a4cb0"/>
+    <p:sldId xmlns:r="http://schemas.openxmlformats.org/officeDocument/2006/relationships" id="258" r:id="R078889a060e14430"/>
+    <p:sldId xmlns:r="http://schemas.openxmlformats.org/officeDocument/2006/relationships" id="259" r:id="R01cb443a87154e58"/>
+    <p:sldId xmlns:r="http://schemas.openxmlformats.org/officeDocument/2006/relationships" id="260" r:id="R101a440a8d3c4134"/>
+    <p:sldId xmlns:r="http://schemas.openxmlformats.org/officeDocument/2006/relationships" id="261" r:id="R01cbdee59e2540d5"/>
+    <p:sldId xmlns:r="http://schemas.openxmlformats.org/officeDocument/2006/relationships" id="262" r:id="Rd0b3d5187de74ecf"/>
+    <p:sldId xmlns:r="http://schemas.openxmlformats.org/officeDocument/2006/relationships" id="263" r:id="R0ce6f8a2a54d4467"/>
+    <p:sldId xmlns:r="http://schemas.openxmlformats.org/officeDocument/2006/relationships" id="264" r:id="R150c6e6f36a74dbc"/>
+    <p:sldId xmlns:r="http://schemas.openxmlformats.org/officeDocument/2006/relationships" id="265" r:id="R2543c271e9694f94"/>
+    <p:sldId xmlns:r="http://schemas.openxmlformats.org/officeDocument/2006/relationships" id="266" r:id="R9ba87ae128d24b02"/>
   </p:sldIdLst>
   <p:sldSz cx="12192000" cy="6858000"/>
   <p:notesSz cx="6858000" cy="9144000"/>
@@ -452,7 +452,7 @@
           <a:lstStyle xmlns:a="http://schemas.openxmlformats.org/drawingml/2006/main"/>
           <a:p xmlns:a="http://schemas.openxmlformats.org/drawingml/2006/main">
             <a:r>
-              <a:t>Kyle Hobson: applied AI workflow design, prompt engineering and enablement. Selected implementations, published teaching and a professional proposal. The generated paper-path cover is decorative, not project evidence.</a:t>
+              <a:t>Kyle Hobson: applied AI workflow design, prompt engineering and enablement. Selected implementations, published teaching and a professional proposal. The cover portrait was supplied by Kyle. The following case slides contain the project evidence and source-status notes.</a:t>
             </a:r>
           </a:p>
         </p:txBody>
@@ -1220,7 +1220,7 @@
   </p:cSld>
   <p:clrMap bg1="lt1" tx1="dk1" bg2="lt2" tx2="dk2" accent1="accent1" accent2="accent2" accent3="accent3" accent4="accent4" accent5="accent5" accent6="accent6" hlink="hlink" folHlink="folHlink"/>
   <p:sldLayoutIdLst>
-    <p:sldLayoutId xmlns:r="http://schemas.openxmlformats.org/officeDocument/2006/relationships" id="2147483649" r:id="R7b8c7793b8724a80"/>
+    <p:sldLayoutId xmlns:r="http://schemas.openxmlformats.org/officeDocument/2006/relationships" id="2147483649" r:id="R60beb0d4cac64816"/>
   </p:sldLayoutIdLst>
   <p:txStyles>
     <p:titleStyle>
@@ -1766,37 +1766,12 @@
       <p:grpSpPr>
         <a:xfrm xmlns:a="http://schemas.openxmlformats.org/drawingml/2006/main"/>
       </p:grpSpPr>
-      <p:pic>
-        <p:nvPicPr>
-          <p:cNvPr id="7" name=""/>
-          <p:cNvPicPr>
-            <a:picLocks xmlns:a="http://schemas.openxmlformats.org/drawingml/2006/main" noChangeAspect="1"/>
-          </p:cNvPicPr>
-          <p:nvPr/>
-        </p:nvPicPr>
-        <p:blipFill>
-          <a:blip xmlns:r="http://schemas.openxmlformats.org/officeDocument/2006/relationships" xmlns:a="http://schemas.openxmlformats.org/drawingml/2006/main" r:embed="Rfb8898af9cd8495d"/>
-          <a:srcRect xmlns:a="http://schemas.openxmlformats.org/drawingml/2006/main" l="0" t="7813" r="0" b="7813"/>
-          <a:stretch xmlns:a="http://schemas.openxmlformats.org/drawingml/2006/main">
-            <a:fillRect l="0" t="0" r="0" b="0"/>
-          </a:stretch>
-        </p:blipFill>
-        <p:spPr>
-          <a:xfrm xmlns:a="http://schemas.openxmlformats.org/drawingml/2006/main">
-            <a:off x="0" y="0"/>
-            <a:ext cx="12192000" cy="6858000"/>
-          </a:xfrm>
-          <a:prstGeom xmlns:a="http://schemas.openxmlformats.org/drawingml/2006/main" prst="rect">
-            <a:avLst/>
-          </a:prstGeom>
-        </p:spPr>
-      </p:pic>
-      <p:sp>
-        <p:nvSpPr>
-          <p:cNvPr id="2" name="section-label">
+      <p:sp>
+        <p:nvSpPr>
+          <p:cNvPr id="7" name="section-label">
             <a:extLst xmlns:a="http://schemas.openxmlformats.org/drawingml/2006/main">
               <a:ext uri="{FF2B5EF4-FFF2-40B4-BE49-F238E27FC236}">
-                <a16:creationId xmlns:a16="http://schemas.microsoft.com/office/drawing/2014/main" id="{7E1AE531-6324-4E75-9C75-F55FD6943C95}"/>
+                <a16:creationId xmlns:a16="http://schemas.microsoft.com/office/drawing/2014/main" id="{8941AD11-4D00-419F-A03E-532A5A1F0775}"/>
               </a:ext>
             </a:extLst>
           </p:cNvPr>
@@ -1854,10 +1829,10 @@
       </p:sp>
       <p:sp>
         <p:nvSpPr>
-          <p:cNvPr id="3" name="headline">
+          <p:cNvPr id="2" name="headline">
             <a:extLst xmlns:a="http://schemas.openxmlformats.org/drawingml/2006/main">
               <a:ext uri="{FF2B5EF4-FFF2-40B4-BE49-F238E27FC236}">
-                <a16:creationId xmlns:a16="http://schemas.microsoft.com/office/drawing/2014/main" id="{C755241E-6EE2-4A87-943B-2F3F381075F5}"/>
+                <a16:creationId xmlns:a16="http://schemas.microsoft.com/office/drawing/2014/main" id="{384D8161-2C0D-4B26-8157-AA53A9D20F75}"/>
               </a:ext>
             </a:extLst>
           </p:cNvPr>
@@ -1868,8 +1843,8 @@
         </p:nvSpPr>
         <p:spPr>
           <a:xfrm xmlns:a="http://schemas.openxmlformats.org/drawingml/2006/main">
-            <a:off x="609600" y="1581150"/>
-            <a:ext cx="8458200" cy="1809750"/>
+            <a:off x="609600" y="1609725"/>
+            <a:ext cx="5953125" cy="1981200"/>
           </a:xfrm>
           <a:prstGeom xmlns:a="http://schemas.openxmlformats.org/drawingml/2006/main" prst="rect">
             <a:avLst/>
@@ -1890,7 +1865,7 @@
                 <a:spcPct val="110000"/>
               </a:lnSpc>
               <a:buNone/>
-              <a:defRPr sz="4650" b="1">
+              <a:defRPr sz="4200" b="1">
                 <a:solidFill>
                   <a:srgbClr val="192B25"/>
                 </a:solidFill>
@@ -1900,7 +1875,7 @@
               </a:defRPr>
             </a:pPr>
             <a:r>
-              <a:rPr sz="4650" b="1">
+              <a:rPr sz="4200" b="1">
                 <a:solidFill>
                   <a:srgbClr val="192B25"/>
                 </a:solidFill>
@@ -1917,7 +1892,7 @@
                 <a:spcPct val="110000"/>
               </a:lnSpc>
               <a:buNone/>
-              <a:defRPr sz="4650" b="1">
+              <a:defRPr sz="4200" b="1">
                 <a:solidFill>
                   <a:srgbClr val="192B25"/>
                 </a:solidFill>
@@ -1927,7 +1902,7 @@
               </a:defRPr>
             </a:pPr>
             <a:r>
-              <a:rPr sz="4650" b="1">
+              <a:rPr sz="4200" b="1">
                 <a:solidFill>
                   <a:srgbClr val="192B25"/>
                 </a:solidFill>
@@ -1940,12 +1915,34 @@
           </a:p>
         </p:txBody>
       </p:sp>
+      <p:pic>
+        <p:nvPicPr>
+          <p:cNvPr id="9" name=""/>
+          <p:cNvPicPr>
+            <a:picLocks xmlns:a="http://schemas.openxmlformats.org/drawingml/2006/main" noChangeAspect="1"/>
+          </p:cNvPicPr>
+          <p:nvPr/>
+        </p:nvPicPr>
+        <p:blipFill>
+          <a:blip xmlns:r="http://schemas.openxmlformats.org/officeDocument/2006/relationships" xmlns:a="http://schemas.openxmlformats.org/drawingml/2006/main" r:embed="Rd10f5bb62b3c4811"/>
+          <a:stretch xmlns:a="http://schemas.openxmlformats.org/drawingml/2006/main"/>
+        </p:blipFill>
+        <p:spPr>
+          <a:xfrm xmlns:a="http://schemas.openxmlformats.org/drawingml/2006/main">
+            <a:off x="7010400" y="1504950"/>
+            <a:ext cx="4572000" cy="4572000"/>
+          </a:xfrm>
+          <a:prstGeom xmlns:a="http://schemas.openxmlformats.org/drawingml/2006/main" prst="rect">
+            <a:avLst/>
+          </a:prstGeom>
+        </p:spPr>
+      </p:pic>
       <p:sp>
         <p:nvSpPr>
           <p:cNvPr id="4" name="cover-intro">
             <a:extLst xmlns:a="http://schemas.openxmlformats.org/drawingml/2006/main">
               <a:ext uri="{FF2B5EF4-FFF2-40B4-BE49-F238E27FC236}">
-                <a16:creationId xmlns:a16="http://schemas.microsoft.com/office/drawing/2014/main" id="{C49128D2-5DF0-4623-B4C4-36C338B38569}"/>
+                <a16:creationId xmlns:a16="http://schemas.microsoft.com/office/drawing/2014/main" id="{25C930DB-5DAF-439E-BB08-DCD96A6CCFCD}"/>
               </a:ext>
             </a:extLst>
           </p:cNvPr>
@@ -1956,8 +1953,8 @@
         </p:nvSpPr>
         <p:spPr>
           <a:xfrm xmlns:a="http://schemas.openxmlformats.org/drawingml/2006/main">
-            <a:off x="647700" y="4067175"/>
-            <a:ext cx="7143750" cy="952500"/>
+            <a:off x="647700" y="4057650"/>
+            <a:ext cx="5676900" cy="1200150"/>
           </a:xfrm>
           <a:prstGeom xmlns:a="http://schemas.openxmlformats.org/drawingml/2006/main" prst="rect">
             <a:avLst/>
@@ -1978,7 +1975,7 @@
                 <a:spcPct val="110000"/>
               </a:lnSpc>
               <a:buNone/>
-              <a:defRPr sz="2100" b="0">
+              <a:defRPr sz="2025" b="0">
                 <a:solidFill>
                   <a:srgbClr val="192B25"/>
                 </a:solidFill>
@@ -1988,7 +1985,7 @@
               </a:defRPr>
             </a:pPr>
             <a:r>
-              <a:rPr sz="2100" b="0">
+              <a:rPr sz="2025" b="0">
                 <a:solidFill>
                   <a:srgbClr val="192B25"/>
                 </a:solidFill>
@@ -1996,16 +1993,16 @@
                 <a:ea typeface="Helvetica Neue"/>
                 <a:cs typeface="Helvetica Neue"/>
               </a:rPr>
-              <a:t>I connect task design, evaluation and teaching</a:t>
-            </a:r>
-          </a:p>
-          <a:p xmlns:a="http://schemas.openxmlformats.org/drawingml/2006/main">
-            <a:pPr>
-              <a:lnSpc>
-                <a:spcPct val="110000"/>
-              </a:lnSpc>
-              <a:buNone/>
-              <a:defRPr sz="2100" b="0">
+              <a:t>I connect task design, evaluation</a:t>
+            </a:r>
+          </a:p>
+          <a:p xmlns:a="http://schemas.openxmlformats.org/drawingml/2006/main">
+            <a:pPr>
+              <a:lnSpc>
+                <a:spcPct val="110000"/>
+              </a:lnSpc>
+              <a:buNone/>
+              <a:defRPr sz="2025" b="0">
                 <a:solidFill>
                   <a:srgbClr val="192B25"/>
                 </a:solidFill>
@@ -2015,7 +2012,7 @@
               </a:defRPr>
             </a:pPr>
             <a:r>
-              <a:rPr sz="2100" b="0">
+              <a:rPr sz="2025" b="0">
                 <a:solidFill>
                   <a:srgbClr val="192B25"/>
                 </a:solidFill>
@@ -2023,7 +2020,34 @@
                 <a:ea typeface="Helvetica Neue"/>
                 <a:cs typeface="Helvetica Neue"/>
               </a:rPr>
-              <a:t>to the people doing the work.</a:t>
+              <a:t>and teaching to the people</a:t>
+            </a:r>
+          </a:p>
+          <a:p xmlns:a="http://schemas.openxmlformats.org/drawingml/2006/main">
+            <a:pPr>
+              <a:lnSpc>
+                <a:spcPct val="110000"/>
+              </a:lnSpc>
+              <a:buNone/>
+              <a:defRPr sz="2025" b="0">
+                <a:solidFill>
+                  <a:srgbClr val="192B25"/>
+                </a:solidFill>
+                <a:latin typeface="Helvetica Neue"/>
+                <a:ea typeface="Helvetica Neue"/>
+                <a:cs typeface="Helvetica Neue"/>
+              </a:defRPr>
+            </a:pPr>
+            <a:r>
+              <a:rPr sz="2025" b="0">
+                <a:solidFill>
+                  <a:srgbClr val="192B25"/>
+                </a:solidFill>
+                <a:latin typeface="Helvetica Neue"/>
+                <a:ea typeface="Helvetica Neue"/>
+                <a:cs typeface="Helvetica Neue"/>
+              </a:rPr>
+              <a:t>doing the work.</a:t>
             </a:r>
           </a:p>
         </p:txBody>
@@ -2033,7 +2057,7 @@
           <p:cNvPr id="5" name="cover-role">
             <a:extLst xmlns:a="http://schemas.openxmlformats.org/drawingml/2006/main">
               <a:ext uri="{FF2B5EF4-FFF2-40B4-BE49-F238E27FC236}">
-                <a16:creationId xmlns:a16="http://schemas.microsoft.com/office/drawing/2014/main" id="{0B24F9E0-4107-4B07-8294-7E4AAF41C742}"/>
+                <a16:creationId xmlns:a16="http://schemas.microsoft.com/office/drawing/2014/main" id="{6CA9CE26-6A26-4821-A6E4-FE682F94E0F7}"/>
               </a:ext>
             </a:extLst>
           </p:cNvPr>
@@ -2044,8 +2068,8 @@
         </p:nvSpPr>
         <p:spPr>
           <a:xfrm xmlns:a="http://schemas.openxmlformats.org/drawingml/2006/main">
-            <a:off x="647700" y="6019800"/>
-            <a:ext cx="8753475" cy="304800"/>
+            <a:off x="647700" y="5972175"/>
+            <a:ext cx="5686425" cy="533400"/>
           </a:xfrm>
           <a:prstGeom xmlns:a="http://schemas.openxmlformats.org/drawingml/2006/main" prst="rect">
             <a:avLst/>
@@ -2066,25 +2090,52 @@
                 <a:spcPct val="110000"/>
               </a:lnSpc>
               <a:buNone/>
-              <a:defRPr sz="1500" b="0">
-                <a:solidFill>
-                  <a:srgbClr val="192B25"/>
-                </a:solidFill>
-                <a:latin typeface="Helvetica Neue"/>
-                <a:ea typeface="Helvetica Neue"/>
-                <a:cs typeface="Helvetica Neue"/>
-              </a:defRPr>
-            </a:pPr>
-            <a:r>
-              <a:rPr sz="1500" b="0">
-                <a:solidFill>
-                  <a:srgbClr val="192B25"/>
-                </a:solidFill>
-                <a:latin typeface="Helvetica Neue"/>
-                <a:ea typeface="Helvetica Neue"/>
-                <a:cs typeface="Helvetica Neue"/>
-              </a:rPr>
-              <a:t>AI workflows · prompt engineering · enablement</a:t>
+              <a:defRPr sz="1425" b="0">
+                <a:solidFill>
+                  <a:srgbClr val="244D3C"/>
+                </a:solidFill>
+                <a:latin typeface="Helvetica Neue"/>
+                <a:ea typeface="Helvetica Neue"/>
+                <a:cs typeface="Helvetica Neue"/>
+              </a:defRPr>
+            </a:pPr>
+            <a:r>
+              <a:rPr sz="1425" b="0">
+                <a:solidFill>
+                  <a:srgbClr val="244D3C"/>
+                </a:solidFill>
+                <a:latin typeface="Helvetica Neue"/>
+                <a:ea typeface="Helvetica Neue"/>
+                <a:cs typeface="Helvetica Neue"/>
+              </a:rPr>
+              <a:t>AI workflows · prompt engineering</a:t>
+            </a:r>
+          </a:p>
+          <a:p xmlns:a="http://schemas.openxmlformats.org/drawingml/2006/main">
+            <a:pPr>
+              <a:lnSpc>
+                <a:spcPct val="110000"/>
+              </a:lnSpc>
+              <a:buNone/>
+              <a:defRPr sz="1425" b="0">
+                <a:solidFill>
+                  <a:srgbClr val="244D3C"/>
+                </a:solidFill>
+                <a:latin typeface="Helvetica Neue"/>
+                <a:ea typeface="Helvetica Neue"/>
+                <a:cs typeface="Helvetica Neue"/>
+              </a:defRPr>
+            </a:pPr>
+            <a:r>
+              <a:rPr sz="1425" b="0">
+                <a:solidFill>
+                  <a:srgbClr val="244D3C"/>
+                </a:solidFill>
+                <a:latin typeface="Helvetica Neue"/>
+                <a:ea typeface="Helvetica Neue"/>
+                <a:cs typeface="Helvetica Neue"/>
+              </a:rPr>
+              <a:t>Teaching and enablement</a:t>
             </a:r>
           </a:p>
         </p:txBody>
@@ -2094,7 +2145,7 @@
           <p:cNvPr id="6" name="slide-number">
             <a:extLst xmlns:a="http://schemas.openxmlformats.org/drawingml/2006/main">
               <a:ext uri="{FF2B5EF4-FFF2-40B4-BE49-F238E27FC236}">
-                <a16:creationId xmlns:a16="http://schemas.microsoft.com/office/drawing/2014/main" id="{B028A810-4063-47C8-8422-79678FBC7B59}"/>
+                <a16:creationId xmlns:a16="http://schemas.microsoft.com/office/drawing/2014/main" id="{26E96E52-B55E-4668-9BD7-C66496BA02D0}"/>
               </a:ext>
             </a:extLst>
           </p:cNvPr>
@@ -2153,7 +2204,7 @@
     </p:spTree>
     <p:extLst>
       <p:ext uri="{BB962C8B-B14F-4D97-AF65-F5344CB8AC3E}">
-        <p14:creationId xmlns:p14="http://schemas.microsoft.com/office/powerpoint/2010/main" val="1416628479"/>
+        <p14:creationId xmlns:p14="http://schemas.microsoft.com/office/powerpoint/2010/main" val="1983171969"/>
       </p:ext>
     </p:extLst>
   </p:cSld>
@@ -2184,7 +2235,7 @@
           <p:cNvPr id="7" name="section-label">
             <a:extLst xmlns:a="http://schemas.openxmlformats.org/drawingml/2006/main">
               <a:ext uri="{FF2B5EF4-FFF2-40B4-BE49-F238E27FC236}">
-                <a16:creationId xmlns:a16="http://schemas.microsoft.com/office/drawing/2014/main" id="{2A5F8B01-B440-440E-A773-51E037DA4C6F}"/>
+                <a16:creationId xmlns:a16="http://schemas.microsoft.com/office/drawing/2014/main" id="{DF2D0410-0E18-4470-B360-0979C0857950}"/>
               </a:ext>
             </a:extLst>
           </p:cNvPr>
@@ -2245,7 +2296,7 @@
           <p:cNvPr id="2" name="headline">
             <a:extLst xmlns:a="http://schemas.openxmlformats.org/drawingml/2006/main">
               <a:ext uri="{FF2B5EF4-FFF2-40B4-BE49-F238E27FC236}">
-                <a16:creationId xmlns:a16="http://schemas.microsoft.com/office/drawing/2014/main" id="{58C9F44C-ED45-4E8A-B801-3260D0037FE4}"/>
+                <a16:creationId xmlns:a16="http://schemas.microsoft.com/office/drawing/2014/main" id="{B2F9A2E2-B222-466C-921A-1469A9EC0D00}"/>
               </a:ext>
             </a:extLst>
           </p:cNvPr>
@@ -2333,7 +2384,7 @@
           <p:cNvPr id="3" name="story-origin">
             <a:extLst xmlns:a="http://schemas.openxmlformats.org/drawingml/2006/main">
               <a:ext uri="{FF2B5EF4-FFF2-40B4-BE49-F238E27FC236}">
-                <a16:creationId xmlns:a16="http://schemas.microsoft.com/office/drawing/2014/main" id="{C48CB351-9AA2-4B25-8E03-F170A28FF5A8}"/>
+                <a16:creationId xmlns:a16="http://schemas.microsoft.com/office/drawing/2014/main" id="{F347451E-1D8E-4D26-8F1A-681AA5EFA125}"/>
               </a:ext>
             </a:extLst>
           </p:cNvPr>
@@ -2394,7 +2445,7 @@
           <p:cNvPr id="4" name="story-ai">
             <a:extLst xmlns:a="http://schemas.openxmlformats.org/drawingml/2006/main">
               <a:ext uri="{FF2B5EF4-FFF2-40B4-BE49-F238E27FC236}">
-                <a16:creationId xmlns:a16="http://schemas.microsoft.com/office/drawing/2014/main" id="{84638C50-286F-4A93-B659-6AC14D0896D9}"/>
+                <a16:creationId xmlns:a16="http://schemas.microsoft.com/office/drawing/2014/main" id="{067B1565-37B5-4B95-B0AF-231E5100A9C2}"/>
               </a:ext>
             </a:extLst>
           </p:cNvPr>
@@ -2459,7 +2510,7 @@
           <p:nvPr/>
         </p:nvPicPr>
         <p:blipFill>
-          <a:blip xmlns:r="http://schemas.openxmlformats.org/officeDocument/2006/relationships" xmlns:a="http://schemas.openxmlformats.org/drawingml/2006/main" r:embed="R494dcb652f24471f"/>
+          <a:blip xmlns:r="http://schemas.openxmlformats.org/officeDocument/2006/relationships" xmlns:a="http://schemas.openxmlformats.org/drawingml/2006/main" r:embed="Rb4d49872975243d8"/>
           <a:stretch xmlns:a="http://schemas.openxmlformats.org/drawingml/2006/main"/>
         </p:blipFill>
         <p:spPr>
@@ -2477,7 +2528,7 @@
           <p:cNvPr id="6" name="slide-number">
             <a:extLst xmlns:a="http://schemas.openxmlformats.org/drawingml/2006/main">
               <a:ext uri="{FF2B5EF4-FFF2-40B4-BE49-F238E27FC236}">
-                <a16:creationId xmlns:a16="http://schemas.microsoft.com/office/drawing/2014/main" id="{4CF90C99-288F-445F-8D98-8A4834536455}"/>
+                <a16:creationId xmlns:a16="http://schemas.microsoft.com/office/drawing/2014/main" id="{458B06C5-9ECC-4648-A7EA-B92DCBD08E61}"/>
               </a:ext>
             </a:extLst>
           </p:cNvPr>
@@ -2536,7 +2587,7 @@
     </p:spTree>
     <p:extLst>
       <p:ext uri="{BB962C8B-B14F-4D97-AF65-F5344CB8AC3E}">
-        <p14:creationId xmlns:p14="http://schemas.microsoft.com/office/powerpoint/2010/main" val="405647311"/>
+        <p14:creationId xmlns:p14="http://schemas.microsoft.com/office/powerpoint/2010/main" val="665758601"/>
       </p:ext>
     </p:extLst>
   </p:cSld>
@@ -2567,7 +2618,7 @@
           <p:cNvPr id="7" name="section-label">
             <a:extLst xmlns:a="http://schemas.openxmlformats.org/drawingml/2006/main">
               <a:ext uri="{FF2B5EF4-FFF2-40B4-BE49-F238E27FC236}">
-                <a16:creationId xmlns:a16="http://schemas.microsoft.com/office/drawing/2014/main" id="{9A7943C3-4E51-46BD-9150-6D083E2D6DDA}"/>
+                <a16:creationId xmlns:a16="http://schemas.microsoft.com/office/drawing/2014/main" id="{064AA452-B3A1-45C1-B33A-80804B0B2385}"/>
               </a:ext>
             </a:extLst>
           </p:cNvPr>
@@ -2628,7 +2679,7 @@
           <p:cNvPr id="2" name="headline">
             <a:extLst xmlns:a="http://schemas.openxmlformats.org/drawingml/2006/main">
               <a:ext uri="{FF2B5EF4-FFF2-40B4-BE49-F238E27FC236}">
-                <a16:creationId xmlns:a16="http://schemas.microsoft.com/office/drawing/2014/main" id="{13B9C585-F846-49D8-8CFB-EA004F4181D2}"/>
+                <a16:creationId xmlns:a16="http://schemas.microsoft.com/office/drawing/2014/main" id="{FEFDF4CC-AA26-4A12-887C-D36F36D7E6F9}"/>
               </a:ext>
             </a:extLst>
           </p:cNvPr>
@@ -2716,7 +2767,7 @@
           <p:cNvPr id="3" name="contact-intent">
             <a:extLst xmlns:a="http://schemas.openxmlformats.org/drawingml/2006/main">
               <a:ext uri="{FF2B5EF4-FFF2-40B4-BE49-F238E27FC236}">
-                <a16:creationId xmlns:a16="http://schemas.microsoft.com/office/drawing/2014/main" id="{1E9AA53D-FA55-4943-B861-0F5EE5F3E69B}"/>
+                <a16:creationId xmlns:a16="http://schemas.microsoft.com/office/drawing/2014/main" id="{4C469B6F-6E36-4606-A85B-7F2040E3A803}"/>
               </a:ext>
             </a:extLst>
           </p:cNvPr>
@@ -2777,7 +2828,7 @@
           <p:cNvPr id="4" name="email">
             <a:extLst xmlns:a="http://schemas.openxmlformats.org/drawingml/2006/main">
               <a:ext uri="{FF2B5EF4-FFF2-40B4-BE49-F238E27FC236}">
-                <a16:creationId xmlns:a16="http://schemas.microsoft.com/office/drawing/2014/main" id="{B46EF380-4D1E-4936-9F09-BDBB44DE403E}"/>
+                <a16:creationId xmlns:a16="http://schemas.microsoft.com/office/drawing/2014/main" id="{60D67BDC-DD06-4E54-A0B0-EB8F31EEEE08}"/>
               </a:ext>
             </a:extLst>
           </p:cNvPr>
@@ -2827,7 +2878,7 @@
                 <a:latin typeface="Helvetica Neue"/>
                 <a:ea typeface="Helvetica Neue"/>
                 <a:cs typeface="Helvetica Neue"/>
-                <a:hlinkClick xmlns:r="http://schemas.openxmlformats.org/officeDocument/2006/relationships" r:id="R5b60a2817279443b"/>
+                <a:hlinkClick xmlns:r="http://schemas.openxmlformats.org/officeDocument/2006/relationships" r:id="Rce14a096a3a84c88"/>
               </a:rPr>
               <a:t>JonathanKyleHobson@gmail.com</a:t>
             </a:r>
@@ -2839,7 +2890,7 @@
           <p:cNvPr id="5" name="portfolio">
             <a:extLst xmlns:a="http://schemas.openxmlformats.org/drawingml/2006/main">
               <a:ext uri="{FF2B5EF4-FFF2-40B4-BE49-F238E27FC236}">
-                <a16:creationId xmlns:a16="http://schemas.microsoft.com/office/drawing/2014/main" id="{5F364635-9775-4D41-AD8C-B68E02C9AF52}"/>
+                <a16:creationId xmlns:a16="http://schemas.microsoft.com/office/drawing/2014/main" id="{06719078-8FA9-48B1-A636-4A9227900AC2}"/>
               </a:ext>
             </a:extLst>
           </p:cNvPr>
@@ -2889,7 +2940,7 @@
                 <a:latin typeface="Helvetica Neue"/>
                 <a:ea typeface="Helvetica Neue"/>
                 <a:cs typeface="Helvetica Neue"/>
-                <a:hlinkClick xmlns:r="http://schemas.openxmlformats.org/officeDocument/2006/relationships" r:id="Rb947d682a3f54069"/>
+                <a:hlinkClick xmlns:r="http://schemas.openxmlformats.org/officeDocument/2006/relationships" r:id="R85cb4237f8d043f9"/>
               </a:rPr>
               <a:t>jonathankhobson.github.io/portfolio/ai</a:t>
             </a:r>
@@ -2901,7 +2952,7 @@
           <p:cNvPr id="6" name="slide-number">
             <a:extLst xmlns:a="http://schemas.openxmlformats.org/drawingml/2006/main">
               <a:ext uri="{FF2B5EF4-FFF2-40B4-BE49-F238E27FC236}">
-                <a16:creationId xmlns:a16="http://schemas.microsoft.com/office/drawing/2014/main" id="{68EE4C60-DFFE-448E-BABD-310C43756530}"/>
+                <a16:creationId xmlns:a16="http://schemas.microsoft.com/office/drawing/2014/main" id="{03FEE3ED-84E0-42A5-ACC0-6B2ADAB464C9}"/>
               </a:ext>
             </a:extLst>
           </p:cNvPr>
@@ -2960,7 +3011,7 @@
     </p:spTree>
     <p:extLst>
       <p:ext uri="{BB962C8B-B14F-4D97-AF65-F5344CB8AC3E}">
-        <p14:creationId xmlns:p14="http://schemas.microsoft.com/office/powerpoint/2010/main" val="1981074957"/>
+        <p14:creationId xmlns:p14="http://schemas.microsoft.com/office/powerpoint/2010/main" val="1497661228"/>
       </p:ext>
     </p:extLst>
   </p:cSld>
@@ -2991,7 +3042,7 @@
           <p:cNvPr id="7" name="section-label">
             <a:extLst xmlns:a="http://schemas.openxmlformats.org/drawingml/2006/main">
               <a:ext uri="{FF2B5EF4-FFF2-40B4-BE49-F238E27FC236}">
-                <a16:creationId xmlns:a16="http://schemas.microsoft.com/office/drawing/2014/main" id="{7F3C120A-A32E-4A65-9CA1-5F789EA7E495}"/>
+                <a16:creationId xmlns:a16="http://schemas.microsoft.com/office/drawing/2014/main" id="{26E54458-2BE8-4898-8CFF-A22AEF608A6D}"/>
               </a:ext>
             </a:extLst>
           </p:cNvPr>
@@ -3052,7 +3103,7 @@
           <p:cNvPr id="2" name="headline">
             <a:extLst xmlns:a="http://schemas.openxmlformats.org/drawingml/2006/main">
               <a:ext uri="{FF2B5EF4-FFF2-40B4-BE49-F238E27FC236}">
-                <a16:creationId xmlns:a16="http://schemas.microsoft.com/office/drawing/2014/main" id="{2D8ECF49-D8E7-4503-A1CD-291ED94102FE}"/>
+                <a16:creationId xmlns:a16="http://schemas.microsoft.com/office/drawing/2014/main" id="{9E5151BE-665E-4BAD-9795-2564A4BC7465}"/>
               </a:ext>
             </a:extLst>
           </p:cNvPr>
@@ -3113,7 +3164,7 @@
           <p:cNvPr id="3" name="prompt-purpose">
             <a:extLst xmlns:a="http://schemas.openxmlformats.org/drawingml/2006/main">
               <a:ext uri="{FF2B5EF4-FFF2-40B4-BE49-F238E27FC236}">
-                <a16:creationId xmlns:a16="http://schemas.microsoft.com/office/drawing/2014/main" id="{BA4FCEE1-773F-443F-B92B-E36C564A27A6}"/>
+                <a16:creationId xmlns:a16="http://schemas.microsoft.com/office/drawing/2014/main" id="{EAEB4DFC-9912-48F3-BF5C-AE61997804FE}"/>
               </a:ext>
             </a:extLst>
           </p:cNvPr>
@@ -3178,7 +3229,7 @@
           <p:nvPr/>
         </p:nvPicPr>
         <p:blipFill>
-          <a:blip xmlns:r="http://schemas.openxmlformats.org/officeDocument/2006/relationships" xmlns:a="http://schemas.openxmlformats.org/drawingml/2006/main" r:embed="R280dc1606b994dca"/>
+          <a:blip xmlns:r="http://schemas.openxmlformats.org/officeDocument/2006/relationships" xmlns:a="http://schemas.openxmlformats.org/drawingml/2006/main" r:embed="R8e0b6c7d72a9476d"/>
           <a:stretch xmlns:a="http://schemas.openxmlformats.org/drawingml/2006/main"/>
         </p:blipFill>
         <p:spPr>
@@ -3196,7 +3247,7 @@
           <p:cNvPr id="5" name="prompt-status">
             <a:extLst xmlns:a="http://schemas.openxmlformats.org/drawingml/2006/main">
               <a:ext uri="{FF2B5EF4-FFF2-40B4-BE49-F238E27FC236}">
-                <a16:creationId xmlns:a16="http://schemas.microsoft.com/office/drawing/2014/main" id="{00E4E58B-9BAF-4FDE-82B8-70407014A8CC}"/>
+                <a16:creationId xmlns:a16="http://schemas.microsoft.com/office/drawing/2014/main" id="{B39D5680-D880-4BEC-9F96-B131B8B4EB95}"/>
               </a:ext>
             </a:extLst>
           </p:cNvPr>
@@ -3257,7 +3308,7 @@
           <p:cNvPr id="6" name="slide-number">
             <a:extLst xmlns:a="http://schemas.openxmlformats.org/drawingml/2006/main">
               <a:ext uri="{FF2B5EF4-FFF2-40B4-BE49-F238E27FC236}">
-                <a16:creationId xmlns:a16="http://schemas.microsoft.com/office/drawing/2014/main" id="{6DCB9564-5DB5-48AD-80D4-9D871ADF1578}"/>
+                <a16:creationId xmlns:a16="http://schemas.microsoft.com/office/drawing/2014/main" id="{F1B088F8-0046-48C7-ACC7-6157BD713878}"/>
               </a:ext>
             </a:extLst>
           </p:cNvPr>
@@ -3316,7 +3367,7 @@
     </p:spTree>
     <p:extLst>
       <p:ext uri="{BB962C8B-B14F-4D97-AF65-F5344CB8AC3E}">
-        <p14:creationId xmlns:p14="http://schemas.microsoft.com/office/powerpoint/2010/main" val="1944758946"/>
+        <p14:creationId xmlns:p14="http://schemas.microsoft.com/office/powerpoint/2010/main" val="2097708785"/>
       </p:ext>
     </p:extLst>
   </p:cSld>
@@ -3347,7 +3398,7 @@
           <p:cNvPr id="10" name="section-label">
             <a:extLst xmlns:a="http://schemas.openxmlformats.org/drawingml/2006/main">
               <a:ext uri="{FF2B5EF4-FFF2-40B4-BE49-F238E27FC236}">
-                <a16:creationId xmlns:a16="http://schemas.microsoft.com/office/drawing/2014/main" id="{344931FA-17D8-475C-9CF1-54D98356333F}"/>
+                <a16:creationId xmlns:a16="http://schemas.microsoft.com/office/drawing/2014/main" id="{EBE9BA27-0EB0-413E-86DF-FFB674E45928}"/>
               </a:ext>
             </a:extLst>
           </p:cNvPr>
@@ -3408,7 +3459,7 @@
           <p:cNvPr id="2" name="headline">
             <a:extLst xmlns:a="http://schemas.openxmlformats.org/drawingml/2006/main">
               <a:ext uri="{FF2B5EF4-FFF2-40B4-BE49-F238E27FC236}">
-                <a16:creationId xmlns:a16="http://schemas.microsoft.com/office/drawing/2014/main" id="{723F7468-4170-4225-845D-687393F02A31}"/>
+                <a16:creationId xmlns:a16="http://schemas.microsoft.com/office/drawing/2014/main" id="{677AD72D-5E51-4B27-B79D-19E173FC070D}"/>
               </a:ext>
             </a:extLst>
           </p:cNvPr>
@@ -3469,7 +3520,7 @@
           <p:cNvPr id="3" name="before-label">
             <a:extLst xmlns:a="http://schemas.openxmlformats.org/drawingml/2006/main">
               <a:ext uri="{FF2B5EF4-FFF2-40B4-BE49-F238E27FC236}">
-                <a16:creationId xmlns:a16="http://schemas.microsoft.com/office/drawing/2014/main" id="{91753B52-ADD9-4B99-AF6B-483D7C093694}"/>
+                <a16:creationId xmlns:a16="http://schemas.microsoft.com/office/drawing/2014/main" id="{2D141EB0-C214-4785-8024-CF7BD7E29513}"/>
               </a:ext>
             </a:extLst>
           </p:cNvPr>
@@ -3530,7 +3581,7 @@
           <p:cNvPr id="4" name="after-label">
             <a:extLst xmlns:a="http://schemas.openxmlformats.org/drawingml/2006/main">
               <a:ext uri="{FF2B5EF4-FFF2-40B4-BE49-F238E27FC236}">
-                <a16:creationId xmlns:a16="http://schemas.microsoft.com/office/drawing/2014/main" id="{3DAB52C3-E5E4-4B14-AF1C-4E96F9C4C0E3}"/>
+                <a16:creationId xmlns:a16="http://schemas.microsoft.com/office/drawing/2014/main" id="{4B8A99CD-C311-4AFC-A510-855F958AF88B}"/>
               </a:ext>
             </a:extLst>
           </p:cNvPr>
@@ -3591,7 +3642,7 @@
           <p:cNvPr id="5" name="before-prompt">
             <a:extLst xmlns:a="http://schemas.openxmlformats.org/drawingml/2006/main">
               <a:ext uri="{FF2B5EF4-FFF2-40B4-BE49-F238E27FC236}">
-                <a16:creationId xmlns:a16="http://schemas.microsoft.com/office/drawing/2014/main" id="{7AFE7CD4-E435-45C0-B1E4-2CDD90F48D68}"/>
+                <a16:creationId xmlns:a16="http://schemas.microsoft.com/office/drawing/2014/main" id="{EE4D86B3-CD16-4EA3-BB8A-E2C518A4E9D3}"/>
               </a:ext>
             </a:extLst>
           </p:cNvPr>
@@ -3652,7 +3703,7 @@
           <p:cNvPr id="6" name="after-prompt">
             <a:extLst xmlns:a="http://schemas.openxmlformats.org/drawingml/2006/main">
               <a:ext uri="{FF2B5EF4-FFF2-40B4-BE49-F238E27FC236}">
-                <a16:creationId xmlns:a16="http://schemas.microsoft.com/office/drawing/2014/main" id="{E668120F-A2F1-407F-8069-72C74F278C1F}"/>
+                <a16:creationId xmlns:a16="http://schemas.microsoft.com/office/drawing/2014/main" id="{F970F969-5663-4C36-AFA0-D2EB65D75BC1}"/>
               </a:ext>
             </a:extLst>
           </p:cNvPr>
@@ -3713,7 +3764,7 @@
           <p:cNvPr id="7" name="expected-winner">
             <a:extLst xmlns:a="http://schemas.openxmlformats.org/drawingml/2006/main">
               <a:ext uri="{FF2B5EF4-FFF2-40B4-BE49-F238E27FC236}">
-                <a16:creationId xmlns:a16="http://schemas.microsoft.com/office/drawing/2014/main" id="{DE8FA3F2-EC41-4D51-A615-FAF4E3239F9F}"/>
+                <a16:creationId xmlns:a16="http://schemas.microsoft.com/office/drawing/2014/main" id="{AA7B7648-9534-4C20-AC57-193C8C34D9A9}"/>
               </a:ext>
             </a:extLst>
           </p:cNvPr>
@@ -3774,7 +3825,7 @@
           <p:cNvPr id="8" name="fixture-reason">
             <a:extLst xmlns:a="http://schemas.openxmlformats.org/drawingml/2006/main">
               <a:ext uri="{FF2B5EF4-FFF2-40B4-BE49-F238E27FC236}">
-                <a16:creationId xmlns:a16="http://schemas.microsoft.com/office/drawing/2014/main" id="{E4B077B6-A50B-4752-A339-EB49D0EE12DE}"/>
+                <a16:creationId xmlns:a16="http://schemas.microsoft.com/office/drawing/2014/main" id="{DF5E24F5-A7C5-414E-8EB3-92E26F0C0CB9}"/>
               </a:ext>
             </a:extLst>
           </p:cNvPr>
@@ -3835,7 +3886,7 @@
           <p:cNvPr id="9" name="slide-number">
             <a:extLst xmlns:a="http://schemas.openxmlformats.org/drawingml/2006/main">
               <a:ext uri="{FF2B5EF4-FFF2-40B4-BE49-F238E27FC236}">
-                <a16:creationId xmlns:a16="http://schemas.microsoft.com/office/drawing/2014/main" id="{DC6A03EB-F869-4DDE-A8FC-54A6A0F1BA1F}"/>
+                <a16:creationId xmlns:a16="http://schemas.microsoft.com/office/drawing/2014/main" id="{CC9BBCD8-2018-4512-9645-B7C65537108F}"/>
               </a:ext>
             </a:extLst>
           </p:cNvPr>
@@ -3894,7 +3945,7 @@
     </p:spTree>
     <p:extLst>
       <p:ext uri="{BB962C8B-B14F-4D97-AF65-F5344CB8AC3E}">
-        <p14:creationId xmlns:p14="http://schemas.microsoft.com/office/powerpoint/2010/main" val="1401663975"/>
+        <p14:creationId xmlns:p14="http://schemas.microsoft.com/office/powerpoint/2010/main" val="1841116108"/>
       </p:ext>
     </p:extLst>
   </p:cSld>
@@ -3925,7 +3976,7 @@
           <p:cNvPr id="8" name="section-label">
             <a:extLst xmlns:a="http://schemas.openxmlformats.org/drawingml/2006/main">
               <a:ext uri="{FF2B5EF4-FFF2-40B4-BE49-F238E27FC236}">
-                <a16:creationId xmlns:a16="http://schemas.microsoft.com/office/drawing/2014/main" id="{656F7F1B-45B7-4BB5-903E-0F461CD09B24}"/>
+                <a16:creationId xmlns:a16="http://schemas.microsoft.com/office/drawing/2014/main" id="{D4B79198-4C29-4B3C-B83E-CF58F560EB94}"/>
               </a:ext>
             </a:extLst>
           </p:cNvPr>
@@ -3986,7 +4037,7 @@
           <p:cNvPr id="2" name="headline">
             <a:extLst xmlns:a="http://schemas.openxmlformats.org/drawingml/2006/main">
               <a:ext uri="{FF2B5EF4-FFF2-40B4-BE49-F238E27FC236}">
-                <a16:creationId xmlns:a16="http://schemas.microsoft.com/office/drawing/2014/main" id="{D777684D-F1E6-475F-B949-786B2BAEF231}"/>
+                <a16:creationId xmlns:a16="http://schemas.microsoft.com/office/drawing/2014/main" id="{C05365F6-8EE0-4935-8D34-316B9DE3B75E}"/>
               </a:ext>
             </a:extLst>
           </p:cNvPr>
@@ -4047,7 +4098,7 @@
           <p:cNvPr id="3" name="host-tool">
             <a:extLst xmlns:a="http://schemas.openxmlformats.org/drawingml/2006/main">
               <a:ext uri="{FF2B5EF4-FFF2-40B4-BE49-F238E27FC236}">
-                <a16:creationId xmlns:a16="http://schemas.microsoft.com/office/drawing/2014/main" id="{BAC140E7-3DD4-4B2E-97E9-604AB9FB25A1}"/>
+                <a16:creationId xmlns:a16="http://schemas.microsoft.com/office/drawing/2014/main" id="{E45B263D-DC33-4483-9F4F-3F1BE28C9A99}"/>
               </a:ext>
             </a:extLst>
           </p:cNvPr>
@@ -4108,7 +4159,7 @@
           <p:cNvPr id="4" name="prompt-next">
             <a:extLst xmlns:a="http://schemas.openxmlformats.org/drawingml/2006/main">
               <a:ext uri="{FF2B5EF4-FFF2-40B4-BE49-F238E27FC236}">
-                <a16:creationId xmlns:a16="http://schemas.microsoft.com/office/drawing/2014/main" id="{77FB8501-B27E-4B30-8E6E-253CFA2C9844}"/>
+                <a16:creationId xmlns:a16="http://schemas.microsoft.com/office/drawing/2014/main" id="{BCAC5DEC-D4B7-4EFD-8A57-0BD94B556560}"/>
               </a:ext>
             </a:extLst>
           </p:cNvPr>
@@ -4173,7 +4224,7 @@
           <p:nvPr/>
         </p:nvPicPr>
         <p:blipFill>
-          <a:blip xmlns:r="http://schemas.openxmlformats.org/officeDocument/2006/relationships" xmlns:a="http://schemas.openxmlformats.org/drawingml/2006/main" r:embed="Rdcf416e82bef4771"/>
+          <a:blip xmlns:r="http://schemas.openxmlformats.org/officeDocument/2006/relationships" xmlns:a="http://schemas.openxmlformats.org/drawingml/2006/main" r:embed="Rc720a3eac4a64446"/>
           <a:stretch xmlns:a="http://schemas.openxmlformats.org/drawingml/2006/main"/>
         </p:blipFill>
         <p:spPr>
@@ -4191,7 +4242,7 @@
           <p:cNvPr id="6" name="session-caption">
             <a:extLst xmlns:a="http://schemas.openxmlformats.org/drawingml/2006/main">
               <a:ext uri="{FF2B5EF4-FFF2-40B4-BE49-F238E27FC236}">
-                <a16:creationId xmlns:a16="http://schemas.microsoft.com/office/drawing/2014/main" id="{5886A024-8728-4CB1-9B7C-64E6F38A65E2}"/>
+                <a16:creationId xmlns:a16="http://schemas.microsoft.com/office/drawing/2014/main" id="{30B28BAC-0DF3-4E24-A943-95323529DFF7}"/>
               </a:ext>
             </a:extLst>
           </p:cNvPr>
@@ -4252,7 +4303,7 @@
           <p:cNvPr id="7" name="slide-number">
             <a:extLst xmlns:a="http://schemas.openxmlformats.org/drawingml/2006/main">
               <a:ext uri="{FF2B5EF4-FFF2-40B4-BE49-F238E27FC236}">
-                <a16:creationId xmlns:a16="http://schemas.microsoft.com/office/drawing/2014/main" id="{8C30C58C-2A36-4B90-975C-F0395A629791}"/>
+                <a16:creationId xmlns:a16="http://schemas.microsoft.com/office/drawing/2014/main" id="{CCF1452C-AF60-4212-992F-3AB84402C479}"/>
               </a:ext>
             </a:extLst>
           </p:cNvPr>
@@ -4311,7 +4362,7 @@
     </p:spTree>
     <p:extLst>
       <p:ext uri="{BB962C8B-B14F-4D97-AF65-F5344CB8AC3E}">
-        <p14:creationId xmlns:p14="http://schemas.microsoft.com/office/powerpoint/2010/main" val="77762121"/>
+        <p14:creationId xmlns:p14="http://schemas.microsoft.com/office/powerpoint/2010/main" val="351091464"/>
       </p:ext>
     </p:extLst>
   </p:cSld>
@@ -4342,7 +4393,7 @@
           <p:cNvPr id="7" name="section-label">
             <a:extLst xmlns:a="http://schemas.openxmlformats.org/drawingml/2006/main">
               <a:ext uri="{FF2B5EF4-FFF2-40B4-BE49-F238E27FC236}">
-                <a16:creationId xmlns:a16="http://schemas.microsoft.com/office/drawing/2014/main" id="{2A2F93C1-6486-4E2D-A466-87B75E5567A9}"/>
+                <a16:creationId xmlns:a16="http://schemas.microsoft.com/office/drawing/2014/main" id="{B3FAF5B9-DA4E-41D2-959E-A375903FAC50}"/>
               </a:ext>
             </a:extLst>
           </p:cNvPr>
@@ -4403,7 +4454,7 @@
           <p:cNvPr id="2" name="headline">
             <a:extLst xmlns:a="http://schemas.openxmlformats.org/drawingml/2006/main">
               <a:ext uri="{FF2B5EF4-FFF2-40B4-BE49-F238E27FC236}">
-                <a16:creationId xmlns:a16="http://schemas.microsoft.com/office/drawing/2014/main" id="{20E50E5F-3097-4A6B-A747-974862BA786C}"/>
+                <a16:creationId xmlns:a16="http://schemas.microsoft.com/office/drawing/2014/main" id="{267E6141-811B-47AA-81F0-DF47FA85A561}"/>
               </a:ext>
             </a:extLst>
           </p:cNvPr>
@@ -4464,7 +4515,7 @@
           <p:cNvPr id="3" name="retrieval-purpose">
             <a:extLst xmlns:a="http://schemas.openxmlformats.org/drawingml/2006/main">
               <a:ext uri="{FF2B5EF4-FFF2-40B4-BE49-F238E27FC236}">
-                <a16:creationId xmlns:a16="http://schemas.microsoft.com/office/drawing/2014/main" id="{978FE464-C219-4714-A7A4-0EE88C44EF9F}"/>
+                <a16:creationId xmlns:a16="http://schemas.microsoft.com/office/drawing/2014/main" id="{F29DB37C-AF07-4284-8AAF-E7C2C7AC472A}"/>
               </a:ext>
             </a:extLst>
           </p:cNvPr>
@@ -4529,7 +4580,7 @@
           <p:nvPr/>
         </p:nvPicPr>
         <p:blipFill>
-          <a:blip xmlns:r="http://schemas.openxmlformats.org/officeDocument/2006/relationships" xmlns:a="http://schemas.openxmlformats.org/drawingml/2006/main" r:embed="Rc706705403d9411a"/>
+          <a:blip xmlns:r="http://schemas.openxmlformats.org/officeDocument/2006/relationships" xmlns:a="http://schemas.openxmlformats.org/drawingml/2006/main" r:embed="R7e5d84f418794afe"/>
           <a:stretch xmlns:a="http://schemas.openxmlformats.org/drawingml/2006/main"/>
         </p:blipFill>
         <p:spPr>
@@ -4547,7 +4598,7 @@
           <p:cNvPr id="5" name="internal-status">
             <a:extLst xmlns:a="http://schemas.openxmlformats.org/drawingml/2006/main">
               <a:ext uri="{FF2B5EF4-FFF2-40B4-BE49-F238E27FC236}">
-                <a16:creationId xmlns:a16="http://schemas.microsoft.com/office/drawing/2014/main" id="{768769E4-E435-451F-9DC0-46FB643595F8}"/>
+                <a16:creationId xmlns:a16="http://schemas.microsoft.com/office/drawing/2014/main" id="{F7D39366-8D44-4608-9175-8BBC4C33DC1D}"/>
               </a:ext>
             </a:extLst>
           </p:cNvPr>
@@ -4608,7 +4659,7 @@
           <p:cNvPr id="6" name="slide-number">
             <a:extLst xmlns:a="http://schemas.openxmlformats.org/drawingml/2006/main">
               <a:ext uri="{FF2B5EF4-FFF2-40B4-BE49-F238E27FC236}">
-                <a16:creationId xmlns:a16="http://schemas.microsoft.com/office/drawing/2014/main" id="{59107575-821E-436C-9BB1-0A89F7C31646}"/>
+                <a16:creationId xmlns:a16="http://schemas.microsoft.com/office/drawing/2014/main" id="{B4AD9D44-EEEB-43EC-AC19-B2DD9B913F0B}"/>
               </a:ext>
             </a:extLst>
           </p:cNvPr>
@@ -4667,7 +4718,7 @@
     </p:spTree>
     <p:extLst>
       <p:ext uri="{BB962C8B-B14F-4D97-AF65-F5344CB8AC3E}">
-        <p14:creationId xmlns:p14="http://schemas.microsoft.com/office/powerpoint/2010/main" val="2003283007"/>
+        <p14:creationId xmlns:p14="http://schemas.microsoft.com/office/powerpoint/2010/main" val="1251512934"/>
       </p:ext>
     </p:extLst>
   </p:cSld>
@@ -4698,7 +4749,7 @@
           <p:cNvPr id="8" name="section-label">
             <a:extLst xmlns:a="http://schemas.openxmlformats.org/drawingml/2006/main">
               <a:ext uri="{FF2B5EF4-FFF2-40B4-BE49-F238E27FC236}">
-                <a16:creationId xmlns:a16="http://schemas.microsoft.com/office/drawing/2014/main" id="{F2B214B1-4A95-4E1C-8503-55DAA7EA44A5}"/>
+                <a16:creationId xmlns:a16="http://schemas.microsoft.com/office/drawing/2014/main" id="{834438D8-1082-4CD1-B0EA-00CA9DFD8DC5}"/>
               </a:ext>
             </a:extLst>
           </p:cNvPr>
@@ -4759,7 +4810,7 @@
           <p:cNvPr id="2" name="headline">
             <a:extLst xmlns:a="http://schemas.openxmlformats.org/drawingml/2006/main">
               <a:ext uri="{FF2B5EF4-FFF2-40B4-BE49-F238E27FC236}">
-                <a16:creationId xmlns:a16="http://schemas.microsoft.com/office/drawing/2014/main" id="{31B5372D-AE39-402F-84BD-DD51C5794286}"/>
+                <a16:creationId xmlns:a16="http://schemas.microsoft.com/office/drawing/2014/main" id="{804D648C-D29C-485B-BC40-B87EB1D9D4BD}"/>
               </a:ext>
             </a:extLst>
           </p:cNvPr>
@@ -4820,7 +4871,7 @@
           <p:cNvPr id="3" name="retrieval-detail">
             <a:extLst xmlns:a="http://schemas.openxmlformats.org/drawingml/2006/main">
               <a:ext uri="{FF2B5EF4-FFF2-40B4-BE49-F238E27FC236}">
-                <a16:creationId xmlns:a16="http://schemas.microsoft.com/office/drawing/2014/main" id="{5C716C65-8986-4BE3-A073-0F3EE6714088}"/>
+                <a16:creationId xmlns:a16="http://schemas.microsoft.com/office/drawing/2014/main" id="{589EFDE3-FAD9-44B3-86DC-651B1B8DCFFC}"/>
               </a:ext>
             </a:extLst>
           </p:cNvPr>
@@ -4881,7 +4932,7 @@
           <p:cNvPr id="4" name="retrieval-review">
             <a:extLst xmlns:a="http://schemas.openxmlformats.org/drawingml/2006/main">
               <a:ext uri="{FF2B5EF4-FFF2-40B4-BE49-F238E27FC236}">
-                <a16:creationId xmlns:a16="http://schemas.microsoft.com/office/drawing/2014/main" id="{7DDEBAEF-3155-4353-AEBD-BA255024024B}"/>
+                <a16:creationId xmlns:a16="http://schemas.microsoft.com/office/drawing/2014/main" id="{BB047336-3A37-4001-B4AA-17B4EF17DEC2}"/>
               </a:ext>
             </a:extLst>
           </p:cNvPr>
@@ -4946,7 +4997,7 @@
           <p:nvPr/>
         </p:nvPicPr>
         <p:blipFill>
-          <a:blip xmlns:r="http://schemas.openxmlformats.org/officeDocument/2006/relationships" xmlns:a="http://schemas.openxmlformats.org/drawingml/2006/main" r:embed="R2db83a4e5ad14b45"/>
+          <a:blip xmlns:r="http://schemas.openxmlformats.org/officeDocument/2006/relationships" xmlns:a="http://schemas.openxmlformats.org/drawingml/2006/main" r:embed="R0a1df8529a2e4b89"/>
           <a:stretch xmlns:a="http://schemas.openxmlformats.org/drawingml/2006/main"/>
         </p:blipFill>
         <p:spPr>
@@ -4964,7 +5015,7 @@
           <p:cNvPr id="6" name="code-caption">
             <a:extLst xmlns:a="http://schemas.openxmlformats.org/drawingml/2006/main">
               <a:ext uri="{FF2B5EF4-FFF2-40B4-BE49-F238E27FC236}">
-                <a16:creationId xmlns:a16="http://schemas.microsoft.com/office/drawing/2014/main" id="{CCA4BA6C-8D85-4C9C-8A5B-F3B346FE4A67}"/>
+                <a16:creationId xmlns:a16="http://schemas.microsoft.com/office/drawing/2014/main" id="{9D7F4478-8A0A-4093-B259-48177A07A153}"/>
               </a:ext>
             </a:extLst>
           </p:cNvPr>
@@ -5025,7 +5076,7 @@
           <p:cNvPr id="7" name="slide-number">
             <a:extLst xmlns:a="http://schemas.openxmlformats.org/drawingml/2006/main">
               <a:ext uri="{FF2B5EF4-FFF2-40B4-BE49-F238E27FC236}">
-                <a16:creationId xmlns:a16="http://schemas.microsoft.com/office/drawing/2014/main" id="{046DCF31-3028-43AD-85FB-FC90EF9A5C5B}"/>
+                <a16:creationId xmlns:a16="http://schemas.microsoft.com/office/drawing/2014/main" id="{ADF85E57-7AD6-4020-AABE-067D6C0E41DF}"/>
               </a:ext>
             </a:extLst>
           </p:cNvPr>
@@ -5084,7 +5135,7 @@
     </p:spTree>
     <p:extLst>
       <p:ext uri="{BB962C8B-B14F-4D97-AF65-F5344CB8AC3E}">
-        <p14:creationId xmlns:p14="http://schemas.microsoft.com/office/powerpoint/2010/main" val="738324159"/>
+        <p14:creationId xmlns:p14="http://schemas.microsoft.com/office/powerpoint/2010/main" val="265239971"/>
       </p:ext>
     </p:extLst>
   </p:cSld>
@@ -5115,7 +5166,7 @@
           <p:cNvPr id="7" name="section-label">
             <a:extLst xmlns:a="http://schemas.openxmlformats.org/drawingml/2006/main">
               <a:ext uri="{FF2B5EF4-FFF2-40B4-BE49-F238E27FC236}">
-                <a16:creationId xmlns:a16="http://schemas.microsoft.com/office/drawing/2014/main" id="{27A1CF10-528D-4F29-8C6C-366AF5F6FB2C}"/>
+                <a16:creationId xmlns:a16="http://schemas.microsoft.com/office/drawing/2014/main" id="{5E6ECA25-28FA-4AAE-B69F-7DFC0775C9D1}"/>
               </a:ext>
             </a:extLst>
           </p:cNvPr>
@@ -5176,7 +5227,7 @@
           <p:cNvPr id="2" name="headline">
             <a:extLst xmlns:a="http://schemas.openxmlformats.org/drawingml/2006/main">
               <a:ext uri="{FF2B5EF4-FFF2-40B4-BE49-F238E27FC236}">
-                <a16:creationId xmlns:a16="http://schemas.microsoft.com/office/drawing/2014/main" id="{95B0CD90-0256-4793-A402-EBF6A4C6F7AE}"/>
+                <a16:creationId xmlns:a16="http://schemas.microsoft.com/office/drawing/2014/main" id="{F9C838C1-58EF-4670-BB66-B20A14108F20}"/>
               </a:ext>
             </a:extLst>
           </p:cNvPr>
@@ -5237,7 +5288,7 @@
           <p:cNvPr id="3" name="course-name">
             <a:extLst xmlns:a="http://schemas.openxmlformats.org/drawingml/2006/main">
               <a:ext uri="{FF2B5EF4-FFF2-40B4-BE49-F238E27FC236}">
-                <a16:creationId xmlns:a16="http://schemas.microsoft.com/office/drawing/2014/main" id="{90485B01-6FDD-4058-B7E5-BE99BDA08FDA}"/>
+                <a16:creationId xmlns:a16="http://schemas.microsoft.com/office/drawing/2014/main" id="{7E208B55-4A7C-43F7-A48F-772F092E109D}"/>
               </a:ext>
             </a:extLst>
           </p:cNvPr>
@@ -5302,7 +5353,7 @@
           <p:nvPr/>
         </p:nvPicPr>
         <p:blipFill>
-          <a:blip xmlns:r="http://schemas.openxmlformats.org/officeDocument/2006/relationships" xmlns:a="http://schemas.openxmlformats.org/drawingml/2006/main" r:embed="Rb616caa7a00e48e7"/>
+          <a:blip xmlns:r="http://schemas.openxmlformats.org/officeDocument/2006/relationships" xmlns:a="http://schemas.openxmlformats.org/drawingml/2006/main" r:embed="Rb061f8002b374141"/>
           <a:stretch xmlns:a="http://schemas.openxmlformats.org/drawingml/2006/main"/>
         </p:blipFill>
         <p:spPr>
@@ -5320,7 +5371,7 @@
           <p:cNvPr id="5" name="course-status">
             <a:extLst xmlns:a="http://schemas.openxmlformats.org/drawingml/2006/main">
               <a:ext uri="{FF2B5EF4-FFF2-40B4-BE49-F238E27FC236}">
-                <a16:creationId xmlns:a16="http://schemas.microsoft.com/office/drawing/2014/main" id="{9ACEE37D-BEF6-4990-A129-2EE1CBCE78E5}"/>
+                <a16:creationId xmlns:a16="http://schemas.microsoft.com/office/drawing/2014/main" id="{173C8D5F-72EA-4F4C-B619-A8F28B5932D8}"/>
               </a:ext>
             </a:extLst>
           </p:cNvPr>
@@ -5381,7 +5432,7 @@
           <p:cNvPr id="6" name="slide-number">
             <a:extLst xmlns:a="http://schemas.openxmlformats.org/drawingml/2006/main">
               <a:ext uri="{FF2B5EF4-FFF2-40B4-BE49-F238E27FC236}">
-                <a16:creationId xmlns:a16="http://schemas.microsoft.com/office/drawing/2014/main" id="{BBBE6708-C77A-4077-9B97-9FE6D6DE5630}"/>
+                <a16:creationId xmlns:a16="http://schemas.microsoft.com/office/drawing/2014/main" id="{F9A7EC11-0DE5-4BAE-AB75-6338ED467E0C}"/>
               </a:ext>
             </a:extLst>
           </p:cNvPr>
@@ -5440,7 +5491,7 @@
     </p:spTree>
     <p:extLst>
       <p:ext uri="{BB962C8B-B14F-4D97-AF65-F5344CB8AC3E}">
-        <p14:creationId xmlns:p14="http://schemas.microsoft.com/office/powerpoint/2010/main" val="1774825060"/>
+        <p14:creationId xmlns:p14="http://schemas.microsoft.com/office/powerpoint/2010/main" val="1186540551"/>
       </p:ext>
     </p:extLst>
   </p:cSld>
@@ -5471,7 +5522,7 @@
           <p:cNvPr id="7" name="section-label">
             <a:extLst xmlns:a="http://schemas.openxmlformats.org/drawingml/2006/main">
               <a:ext uri="{FF2B5EF4-FFF2-40B4-BE49-F238E27FC236}">
-                <a16:creationId xmlns:a16="http://schemas.microsoft.com/office/drawing/2014/main" id="{9D6B4F1B-800C-4F55-A976-B9C86A21A5E9}"/>
+                <a16:creationId xmlns:a16="http://schemas.microsoft.com/office/drawing/2014/main" id="{5C68743F-D9AC-4922-BDBB-F861A8B91C28}"/>
               </a:ext>
             </a:extLst>
           </p:cNvPr>
@@ -5532,7 +5583,7 @@
           <p:cNvPr id="2" name="headline">
             <a:extLst xmlns:a="http://schemas.openxmlformats.org/drawingml/2006/main">
               <a:ext uri="{FF2B5EF4-FFF2-40B4-BE49-F238E27FC236}">
-                <a16:creationId xmlns:a16="http://schemas.microsoft.com/office/drawing/2014/main" id="{928B161C-DE4D-47C4-8AD6-BD671550670D}"/>
+                <a16:creationId xmlns:a16="http://schemas.microsoft.com/office/drawing/2014/main" id="{D52CB012-4CED-4D11-B03F-759D274C503B}"/>
               </a:ext>
             </a:extLst>
           </p:cNvPr>
@@ -5593,7 +5644,7 @@
           <p:cNvPr id="3" name="course-example-context">
             <a:extLst xmlns:a="http://schemas.openxmlformats.org/drawingml/2006/main">
               <a:ext uri="{FF2B5EF4-FFF2-40B4-BE49-F238E27FC236}">
-                <a16:creationId xmlns:a16="http://schemas.microsoft.com/office/drawing/2014/main" id="{75E5F310-70CA-434F-B298-250E5462BAC9}"/>
+                <a16:creationId xmlns:a16="http://schemas.microsoft.com/office/drawing/2014/main" id="{8F1EC61F-E550-4E73-85C9-3FA80D4B1A43}"/>
               </a:ext>
             </a:extLst>
           </p:cNvPr>
@@ -5658,7 +5709,7 @@
           <p:nvPr/>
         </p:nvPicPr>
         <p:blipFill>
-          <a:blip xmlns:r="http://schemas.openxmlformats.org/officeDocument/2006/relationships" xmlns:a="http://schemas.openxmlformats.org/drawingml/2006/main" r:embed="R15bee62d02834da6"/>
+          <a:blip xmlns:r="http://schemas.openxmlformats.org/officeDocument/2006/relationships" xmlns:a="http://schemas.openxmlformats.org/drawingml/2006/main" r:embed="R36b6a668f246473e"/>
           <a:stretch xmlns:a="http://schemas.openxmlformats.org/drawingml/2006/main"/>
         </p:blipFill>
         <p:spPr>
@@ -5676,7 +5727,7 @@
           <p:cNvPr id="5" name="transfer-assessment">
             <a:extLst xmlns:a="http://schemas.openxmlformats.org/drawingml/2006/main">
               <a:ext uri="{FF2B5EF4-FFF2-40B4-BE49-F238E27FC236}">
-                <a16:creationId xmlns:a16="http://schemas.microsoft.com/office/drawing/2014/main" id="{0D460604-C6D3-4CBF-A968-27160D44DFAD}"/>
+                <a16:creationId xmlns:a16="http://schemas.microsoft.com/office/drawing/2014/main" id="{F2C99E60-5AB7-40A0-A7F8-5EDA2923E6F9}"/>
               </a:ext>
             </a:extLst>
           </p:cNvPr>
@@ -5737,7 +5788,7 @@
           <p:cNvPr id="6" name="slide-number">
             <a:extLst xmlns:a="http://schemas.openxmlformats.org/drawingml/2006/main">
               <a:ext uri="{FF2B5EF4-FFF2-40B4-BE49-F238E27FC236}">
-                <a16:creationId xmlns:a16="http://schemas.microsoft.com/office/drawing/2014/main" id="{76C1EBA2-6B62-4B47-B5B6-8037AF9CC2CB}"/>
+                <a16:creationId xmlns:a16="http://schemas.microsoft.com/office/drawing/2014/main" id="{4562E46C-C816-44D0-B56B-A34CECD83507}"/>
               </a:ext>
             </a:extLst>
           </p:cNvPr>
@@ -5796,7 +5847,7 @@
     </p:spTree>
     <p:extLst>
       <p:ext uri="{BB962C8B-B14F-4D97-AF65-F5344CB8AC3E}">
-        <p14:creationId xmlns:p14="http://schemas.microsoft.com/office/powerpoint/2010/main" val="380144294"/>
+        <p14:creationId xmlns:p14="http://schemas.microsoft.com/office/powerpoint/2010/main" val="168053126"/>
       </p:ext>
     </p:extLst>
   </p:cSld>
@@ -5827,7 +5878,7 @@
           <p:cNvPr id="7" name="section-label">
             <a:extLst xmlns:a="http://schemas.openxmlformats.org/drawingml/2006/main">
               <a:ext uri="{FF2B5EF4-FFF2-40B4-BE49-F238E27FC236}">
-                <a16:creationId xmlns:a16="http://schemas.microsoft.com/office/drawing/2014/main" id="{695BA026-EA05-4731-8EAC-BE75FAF0D588}"/>
+                <a16:creationId xmlns:a16="http://schemas.microsoft.com/office/drawing/2014/main" id="{1C6FCB76-44E2-4302-9C93-68671AA29397}"/>
               </a:ext>
             </a:extLst>
           </p:cNvPr>
@@ -5888,7 +5939,7 @@
           <p:cNvPr id="2" name="headline">
             <a:extLst xmlns:a="http://schemas.openxmlformats.org/drawingml/2006/main">
               <a:ext uri="{FF2B5EF4-FFF2-40B4-BE49-F238E27FC236}">
-                <a16:creationId xmlns:a16="http://schemas.microsoft.com/office/drawing/2014/main" id="{B077494D-450B-43FD-AF37-A9BFE3137541}"/>
+                <a16:creationId xmlns:a16="http://schemas.microsoft.com/office/drawing/2014/main" id="{F19B4A0E-C508-4538-B93B-C8A944942307}"/>
               </a:ext>
             </a:extLst>
           </p:cNvPr>
@@ -5976,7 +6027,7 @@
           <p:cNvPr id="3" name="asu-purpose">
             <a:extLst xmlns:a="http://schemas.openxmlformats.org/drawingml/2006/main">
               <a:ext uri="{FF2B5EF4-FFF2-40B4-BE49-F238E27FC236}">
-                <a16:creationId xmlns:a16="http://schemas.microsoft.com/office/drawing/2014/main" id="{9222E855-B890-42A2-942F-527D77935E0E}"/>
+                <a16:creationId xmlns:a16="http://schemas.microsoft.com/office/drawing/2014/main" id="{75702E99-75D7-42DE-8E2A-0367131826AD}"/>
               </a:ext>
             </a:extLst>
           </p:cNvPr>
@@ -6041,7 +6092,7 @@
           <p:nvPr/>
         </p:nvPicPr>
         <p:blipFill>
-          <a:blip xmlns:r="http://schemas.openxmlformats.org/officeDocument/2006/relationships" xmlns:a="http://schemas.openxmlformats.org/drawingml/2006/main" r:embed="R6b6c6c7c1df34452"/>
+          <a:blip xmlns:r="http://schemas.openxmlformats.org/officeDocument/2006/relationships" xmlns:a="http://schemas.openxmlformats.org/drawingml/2006/main" r:embed="R7a3ab35639694787"/>
           <a:stretch xmlns:a="http://schemas.openxmlformats.org/drawingml/2006/main"/>
         </p:blipFill>
         <p:spPr>
@@ -6059,7 +6110,7 @@
           <p:cNvPr id="5" name="asu-stage">
             <a:extLst xmlns:a="http://schemas.openxmlformats.org/drawingml/2006/main">
               <a:ext uri="{FF2B5EF4-FFF2-40B4-BE49-F238E27FC236}">
-                <a16:creationId xmlns:a16="http://schemas.microsoft.com/office/drawing/2014/main" id="{CEC05E03-8FC3-4CCB-956A-49555514DB3B}"/>
+                <a16:creationId xmlns:a16="http://schemas.microsoft.com/office/drawing/2014/main" id="{51E3DBB0-8C58-4035-8707-D03096E5A1E3}"/>
               </a:ext>
             </a:extLst>
           </p:cNvPr>
@@ -6120,7 +6171,7 @@
           <p:cNvPr id="6" name="slide-number">
             <a:extLst xmlns:a="http://schemas.openxmlformats.org/drawingml/2006/main">
               <a:ext uri="{FF2B5EF4-FFF2-40B4-BE49-F238E27FC236}">
-                <a16:creationId xmlns:a16="http://schemas.microsoft.com/office/drawing/2014/main" id="{C9DCFDCA-6A5B-4600-8BC0-FFFD28D01974}"/>
+                <a16:creationId xmlns:a16="http://schemas.microsoft.com/office/drawing/2014/main" id="{0583DDD3-E16F-4545-892B-E17C2D02F926}"/>
               </a:ext>
             </a:extLst>
           </p:cNvPr>
@@ -6179,7 +6230,7 @@
     </p:spTree>
     <p:extLst>
       <p:ext uri="{BB962C8B-B14F-4D97-AF65-F5344CB8AC3E}">
-        <p14:creationId xmlns:p14="http://schemas.microsoft.com/office/powerpoint/2010/main" val="1769782827"/>
+        <p14:creationId xmlns:p14="http://schemas.microsoft.com/office/powerpoint/2010/main" val="1754087495"/>
       </p:ext>
     </p:extLst>
   </p:cSld>

</xml_diff>